<commit_message>
Slider- Delete slider feature
</commit_message>
<xml_diff>
--- a/.lessons/54 Slider Features/8 Slider- Update Slider image issue fix/1.pptx
+++ b/.lessons/54 Slider Features/8 Slider- Update Slider image issue fix/1.pptx
@@ -7,7 +7,10 @@
   <p:sldIdLst>
     <p:sldId id="413" r:id="rId2"/>
     <p:sldId id="414" r:id="rId3"/>
-    <p:sldId id="400" r:id="rId4"/>
+    <p:sldId id="415" r:id="rId4"/>
+    <p:sldId id="400" r:id="rId5"/>
+    <p:sldId id="416" r:id="rId6"/>
+    <p:sldId id="417" r:id="rId7"/>
   </p:sldIdLst>
   <p:sldSz cx="12192000" cy="6858000"/>
   <p:notesSz cx="6858000" cy="9144000"/>
@@ -261,7 +264,7 @@
           <a:p>
             <a:fld id="{3E102D2E-813C-461C-9963-687A650C48C0}" type="datetimeFigureOut">
               <a:rPr lang="en-US" smtClean="0"/>
-              <a:t>6/26/2025</a:t>
+              <a:t>8/8/2025</a:t>
             </a:fld>
             <a:endParaRPr lang="en-US"/>
           </a:p>
@@ -459,7 +462,7 @@
           <a:p>
             <a:fld id="{3E102D2E-813C-461C-9963-687A650C48C0}" type="datetimeFigureOut">
               <a:rPr lang="en-US" smtClean="0"/>
-              <a:t>6/26/2025</a:t>
+              <a:t>8/8/2025</a:t>
             </a:fld>
             <a:endParaRPr lang="en-US"/>
           </a:p>
@@ -667,7 +670,7 @@
           <a:p>
             <a:fld id="{3E102D2E-813C-461C-9963-687A650C48C0}" type="datetimeFigureOut">
               <a:rPr lang="en-US" smtClean="0"/>
-              <a:t>6/26/2025</a:t>
+              <a:t>8/8/2025</a:t>
             </a:fld>
             <a:endParaRPr lang="en-US"/>
           </a:p>
@@ -865,7 +868,7 @@
           <a:p>
             <a:fld id="{3E102D2E-813C-461C-9963-687A650C48C0}" type="datetimeFigureOut">
               <a:rPr lang="en-US" smtClean="0"/>
-              <a:t>6/26/2025</a:t>
+              <a:t>8/8/2025</a:t>
             </a:fld>
             <a:endParaRPr lang="en-US"/>
           </a:p>
@@ -1140,7 +1143,7 @@
           <a:p>
             <a:fld id="{3E102D2E-813C-461C-9963-687A650C48C0}" type="datetimeFigureOut">
               <a:rPr lang="en-US" smtClean="0"/>
-              <a:t>6/26/2025</a:t>
+              <a:t>8/8/2025</a:t>
             </a:fld>
             <a:endParaRPr lang="en-US"/>
           </a:p>
@@ -1405,7 +1408,7 @@
           <a:p>
             <a:fld id="{3E102D2E-813C-461C-9963-687A650C48C0}" type="datetimeFigureOut">
               <a:rPr lang="en-US" smtClean="0"/>
-              <a:t>6/26/2025</a:t>
+              <a:t>8/8/2025</a:t>
             </a:fld>
             <a:endParaRPr lang="en-US"/>
           </a:p>
@@ -1817,7 +1820,7 @@
           <a:p>
             <a:fld id="{3E102D2E-813C-461C-9963-687A650C48C0}" type="datetimeFigureOut">
               <a:rPr lang="en-US" smtClean="0"/>
-              <a:t>6/26/2025</a:t>
+              <a:t>8/8/2025</a:t>
             </a:fld>
             <a:endParaRPr lang="en-US"/>
           </a:p>
@@ -1958,7 +1961,7 @@
           <a:p>
             <a:fld id="{3E102D2E-813C-461C-9963-687A650C48C0}" type="datetimeFigureOut">
               <a:rPr lang="en-US" smtClean="0"/>
-              <a:t>6/26/2025</a:t>
+              <a:t>8/8/2025</a:t>
             </a:fld>
             <a:endParaRPr lang="en-US"/>
           </a:p>
@@ -2071,7 +2074,7 @@
           <a:p>
             <a:fld id="{3E102D2E-813C-461C-9963-687A650C48C0}" type="datetimeFigureOut">
               <a:rPr lang="en-US" smtClean="0"/>
-              <a:t>6/26/2025</a:t>
+              <a:t>8/8/2025</a:t>
             </a:fld>
             <a:endParaRPr lang="en-US"/>
           </a:p>
@@ -2382,7 +2385,7 @@
           <a:p>
             <a:fld id="{3E102D2E-813C-461C-9963-687A650C48C0}" type="datetimeFigureOut">
               <a:rPr lang="en-US" smtClean="0"/>
-              <a:t>6/26/2025</a:t>
+              <a:t>8/8/2025</a:t>
             </a:fld>
             <a:endParaRPr lang="en-US"/>
           </a:p>
@@ -2670,7 +2673,7 @@
           <a:p>
             <a:fld id="{3E102D2E-813C-461C-9963-687A650C48C0}" type="datetimeFigureOut">
               <a:rPr lang="en-US" smtClean="0"/>
-              <a:t>6/26/2025</a:t>
+              <a:t>8/8/2025</a:t>
             </a:fld>
             <a:endParaRPr lang="en-US"/>
           </a:p>
@@ -2911,7 +2914,7 @@
           <a:p>
             <a:fld id="{3E102D2E-813C-461C-9963-687A650C48C0}" type="datetimeFigureOut">
               <a:rPr lang="en-US" smtClean="0"/>
-              <a:t>6/26/2025</a:t>
+              <a:t>8/8/2025</a:t>
             </a:fld>
             <a:endParaRPr lang="en-US"/>
           </a:p>
@@ -3349,7 +3352,7 @@
         <p:spPr>
           <a:xfrm>
             <a:off x="217714" y="255046"/>
-            <a:ext cx="11756571" cy="355354"/>
+            <a:ext cx="11756571" cy="955518"/>
           </a:xfrm>
           <a:prstGeom prst="rect">
             <a:avLst/>
@@ -3369,7 +3372,56 @@
               <a:buNone/>
             </a:pPr>
             <a:r>
-              <a:rPr kumimoji="0" lang="en-US" altLang="en-US" sz="1300" b="0" i="0" u="none" strike="noStrike" cap="none" normalizeH="0" baseline="0">
+              <a:rPr lang="az-Latn-AZ" altLang="en-US" sz="1300">
+                <a:latin typeface="Arial" panose="020B0604020202020204" pitchFamily="34" charset="0"/>
+              </a:rPr>
+              <a:t>Heçnə etmədən sadəcə </a:t>
+            </a:r>
+            <a:r>
+              <a:rPr lang="az-Latn-AZ" altLang="en-US" sz="1300" b="1">
+                <a:latin typeface="Arial" panose="020B0604020202020204" pitchFamily="34" charset="0"/>
+              </a:rPr>
+              <a:t>EDİT</a:t>
+            </a:r>
+            <a:r>
+              <a:rPr lang="az-Latn-AZ" altLang="en-US" sz="1300">
+                <a:latin typeface="Arial" panose="020B0604020202020204" pitchFamily="34" charset="0"/>
+              </a:rPr>
+              <a:t> səhifəsinə daxil olub </a:t>
+            </a:r>
+            <a:r>
+              <a:rPr lang="az-Latn-AZ" altLang="en-US" sz="1300" b="1">
+                <a:latin typeface="Arial" panose="020B0604020202020204" pitchFamily="34" charset="0"/>
+              </a:rPr>
+              <a:t>UPDATE</a:t>
+            </a:r>
+            <a:r>
+              <a:rPr lang="az-Latn-AZ" altLang="en-US" sz="1300">
+                <a:latin typeface="Arial" panose="020B0604020202020204" pitchFamily="34" charset="0"/>
+              </a:rPr>
+              <a:t> düyməsini kliklədikdə, şəkil itir. Bunu düzəltmək lazımdır. 	</a:t>
+            </a:r>
+          </a:p>
+          <a:p>
+            <a:pPr>
+              <a:lnSpc>
+                <a:spcPct val="150000"/>
+              </a:lnSpc>
+              <a:buNone/>
+            </a:pPr>
+            <a:endParaRPr lang="az-Latn-AZ" altLang="en-US" sz="1300">
+              <a:latin typeface="Arial" panose="020B0604020202020204" pitchFamily="34" charset="0"/>
+            </a:endParaRPr>
+          </a:p>
+          <a:p>
+            <a:pPr>
+              <a:lnSpc>
+                <a:spcPct val="150000"/>
+              </a:lnSpc>
+              <a:buNone/>
+            </a:pPr>
+            <a:r>
+              <a:rPr kumimoji="0" lang="az-Latn-AZ" altLang="en-US" sz="1300" b="0" i="0" u="none" strike="noStrike" cap="none" normalizeH="0" baseline="0">
                 <a:ln>
                   <a:noFill/>
                 </a:ln>
@@ -3379,11 +3431,107 @@
                 <a:effectLst/>
                 <a:latin typeface="Arial" panose="020B0604020202020204" pitchFamily="34" charset="0"/>
               </a:rPr>
-              <a:t>.</a:t>
-            </a:r>
-          </a:p>
-        </p:txBody>
-      </p:sp>
+              <a:t>B</a:t>
+            </a:r>
+            <a:r>
+              <a:rPr lang="az-Latn-AZ" altLang="en-US" sz="1300">
+                <a:latin typeface="Arial" panose="020B0604020202020204" pitchFamily="34" charset="0"/>
+              </a:rPr>
+              <a:t>irdəki, kontrollerdə </a:t>
+            </a:r>
+            <a:r>
+              <a:rPr lang="az-Latn-AZ" altLang="en-US" sz="1300" b="1">
+                <a:latin typeface="Arial" panose="020B0604020202020204" pitchFamily="34" charset="0"/>
+              </a:rPr>
+              <a:t>update() </a:t>
+            </a:r>
+            <a:r>
+              <a:rPr lang="az-Latn-AZ" altLang="en-US" sz="1300">
+                <a:latin typeface="Arial" panose="020B0604020202020204" pitchFamily="34" charset="0"/>
+              </a:rPr>
+              <a:t>funksiyasında </a:t>
+            </a:r>
+            <a:r>
+              <a:rPr lang="az-Latn-AZ" altLang="en-US" sz="1300" b="1">
+                <a:latin typeface="Arial" panose="020B0604020202020204" pitchFamily="34" charset="0"/>
+              </a:rPr>
+              <a:t>updateİmage() </a:t>
+            </a:r>
+            <a:r>
+              <a:rPr lang="az-Latn-AZ" altLang="en-US" sz="1300">
+                <a:latin typeface="Arial" panose="020B0604020202020204" pitchFamily="34" charset="0"/>
+              </a:rPr>
+              <a:t>metodu əvəzinə </a:t>
+            </a:r>
+            <a:r>
+              <a:rPr lang="az-Latn-AZ" altLang="en-US" sz="1300" b="1">
+                <a:latin typeface="Arial" panose="020B0604020202020204" pitchFamily="34" charset="0"/>
+              </a:rPr>
+              <a:t>uploadİmage() </a:t>
+            </a:r>
+            <a:r>
+              <a:rPr lang="az-Latn-AZ" altLang="en-US" sz="1300">
+                <a:latin typeface="Arial" panose="020B0604020202020204" pitchFamily="34" charset="0"/>
+              </a:rPr>
+              <a:t>yazmışam. Bunuda düzəltmək lazımdır.</a:t>
+            </a:r>
+            <a:endParaRPr kumimoji="0" lang="en-US" altLang="en-US" sz="1300" b="0" i="0" u="none" strike="noStrike" cap="none" normalizeH="0" baseline="0">
+              <a:ln>
+                <a:noFill/>
+              </a:ln>
+              <a:solidFill>
+                <a:schemeClr val="tx1"/>
+              </a:solidFill>
+              <a:effectLst/>
+              <a:latin typeface="Arial" panose="020B0604020202020204" pitchFamily="34" charset="0"/>
+            </a:endParaRPr>
+          </a:p>
+        </p:txBody>
+      </p:sp>
+      <p:pic>
+        <p:nvPicPr>
+          <p:cNvPr id="4" name="Picture 3">
+            <a:extLst>
+              <a:ext uri="{FF2B5EF4-FFF2-40B4-BE49-F238E27FC236}">
+                <a16:creationId xmlns:a16="http://schemas.microsoft.com/office/drawing/2014/main" id="{343D3D11-20A3-B0E3-DDC9-AA7C8C2E6130}"/>
+              </a:ext>
+            </a:extLst>
+          </p:cNvPr>
+          <p:cNvPicPr>
+            <a:picLocks noChangeAspect="1"/>
+          </p:cNvPicPr>
+          <p:nvPr/>
+        </p:nvPicPr>
+        <p:blipFill>
+          <a:blip r:embed="rId2"/>
+          <a:stretch>
+            <a:fillRect/>
+          </a:stretch>
+        </p:blipFill>
+        <p:spPr>
+          <a:xfrm>
+            <a:off x="4526621" y="1542473"/>
+            <a:ext cx="7665378" cy="5315526"/>
+          </a:xfrm>
+          <a:prstGeom prst="rect">
+            <a:avLst/>
+          </a:prstGeom>
+          <a:ln w="38100" cap="sq">
+            <a:solidFill>
+              <a:srgbClr val="000000"/>
+            </a:solidFill>
+            <a:prstDash val="solid"/>
+            <a:miter lim="800000"/>
+          </a:ln>
+          <a:effectLst>
+            <a:outerShdw blurRad="50800" dist="38100" dir="2700000" algn="tl" rotWithShape="0">
+              <a:srgbClr val="000000">
+                <a:alpha val="43000"/>
+              </a:srgbClr>
+            </a:outerShdw>
+          </a:effectLst>
+        </p:spPr>
+      </p:pic>
     </p:spTree>
     <p:extLst>
       <p:ext uri="{BB962C8B-B14F-4D97-AF65-F5344CB8AC3E}">
@@ -3434,8 +3582,8 @@
         </p:nvSpPr>
         <p:spPr>
           <a:xfrm>
-            <a:off x="217714" y="255046"/>
-            <a:ext cx="11756571" cy="355354"/>
+            <a:off x="217714" y="134974"/>
+            <a:ext cx="11756571" cy="335156"/>
           </a:xfrm>
           <a:prstGeom prst="rect">
             <a:avLst/>
@@ -3455,21 +3603,110 @@
               <a:buNone/>
             </a:pPr>
             <a:r>
-              <a:rPr kumimoji="0" lang="en-US" altLang="en-US" sz="1300" b="0" i="0" u="none" strike="noStrike" cap="none" normalizeH="0" baseline="0">
-                <a:ln>
-                  <a:noFill/>
-                </a:ln>
-                <a:solidFill>
-                  <a:schemeClr val="tx1"/>
-                </a:solidFill>
-                <a:effectLst/>
-                <a:latin typeface="Arial" panose="020B0604020202020204" pitchFamily="34" charset="0"/>
-              </a:rPr>
-              <a:t>.</a:t>
-            </a:r>
-          </a:p>
-        </p:txBody>
-      </p:sp>
+              <a:rPr lang="en-US" altLang="en-US" sz="1200">
+                <a:latin typeface="Arial" panose="020B0604020202020204" pitchFamily="34" charset="0"/>
+              </a:rPr>
+              <a:t>Bunun olmamas</a:t>
+            </a:r>
+            <a:r>
+              <a:rPr lang="az-Latn-AZ" altLang="en-US" sz="1200">
+                <a:latin typeface="Arial" panose="020B0604020202020204" pitchFamily="34" charset="0"/>
+              </a:rPr>
+              <a:t>ı üçün </a:t>
+            </a:r>
+            <a:r>
+              <a:rPr lang="az-Latn-AZ" altLang="en-US" sz="1200" b="1">
+                <a:latin typeface="Arial" panose="020B0604020202020204" pitchFamily="34" charset="0"/>
+              </a:rPr>
+              <a:t>empty() </a:t>
+            </a:r>
+            <a:r>
+              <a:rPr lang="az-Latn-AZ" altLang="en-US" sz="1200">
+                <a:latin typeface="Arial" panose="020B0604020202020204" pitchFamily="34" charset="0"/>
+              </a:rPr>
+              <a:t>funksiyası istifadə edərək deyəcəyik ki, əgər gələn dəyər </a:t>
+            </a:r>
+            <a:r>
+              <a:rPr lang="az-Latn-AZ" altLang="en-US" sz="1200" b="1">
+                <a:latin typeface="Arial" panose="020B0604020202020204" pitchFamily="34" charset="0"/>
+              </a:rPr>
+              <a:t>NULL</a:t>
+            </a:r>
+            <a:r>
+              <a:rPr lang="az-Latn-AZ" altLang="en-US" sz="1200">
+                <a:latin typeface="Arial" panose="020B0604020202020204" pitchFamily="34" charset="0"/>
+              </a:rPr>
+              <a:t> deyiləs </a:t>
+            </a:r>
+            <a:r>
+              <a:rPr lang="az-Latn-AZ" altLang="en-US" sz="1200" b="1">
+                <a:latin typeface="Arial" panose="020B0604020202020204" pitchFamily="34" charset="0"/>
+              </a:rPr>
+              <a:t>banner</a:t>
+            </a:r>
+            <a:r>
+              <a:rPr lang="az-Latn-AZ" altLang="en-US" sz="1200">
+                <a:latin typeface="Arial" panose="020B0604020202020204" pitchFamily="34" charset="0"/>
+              </a:rPr>
+              <a:t> sütununa nəsə yaz. Əks halda heçnə etməyəcək.</a:t>
+            </a:r>
+            <a:endParaRPr kumimoji="0" lang="en-US" altLang="en-US" sz="1200" b="0" i="0" u="none" strike="noStrike" cap="none" normalizeH="0" baseline="0">
+              <a:ln>
+                <a:noFill/>
+              </a:ln>
+              <a:solidFill>
+                <a:schemeClr val="tx1"/>
+              </a:solidFill>
+              <a:effectLst/>
+              <a:latin typeface="Arial" panose="020B0604020202020204" pitchFamily="34" charset="0"/>
+            </a:endParaRPr>
+          </a:p>
+        </p:txBody>
+      </p:sp>
+      <p:pic>
+        <p:nvPicPr>
+          <p:cNvPr id="4" name="Picture 3">
+            <a:extLst>
+              <a:ext uri="{FF2B5EF4-FFF2-40B4-BE49-F238E27FC236}">
+                <a16:creationId xmlns:a16="http://schemas.microsoft.com/office/drawing/2014/main" id="{01E74578-B387-8D81-86DB-805BE532271C}"/>
+              </a:ext>
+            </a:extLst>
+          </p:cNvPr>
+          <p:cNvPicPr>
+            <a:picLocks noChangeAspect="1"/>
+          </p:cNvPicPr>
+          <p:nvPr/>
+        </p:nvPicPr>
+        <p:blipFill>
+          <a:blip r:embed="rId2"/>
+          <a:stretch>
+            <a:fillRect/>
+          </a:stretch>
+        </p:blipFill>
+        <p:spPr>
+          <a:xfrm>
+            <a:off x="0" y="650817"/>
+            <a:ext cx="12192000" cy="6207183"/>
+          </a:xfrm>
+          <a:prstGeom prst="rect">
+            <a:avLst/>
+          </a:prstGeom>
+          <a:ln w="38100" cap="sq">
+            <a:solidFill>
+              <a:srgbClr val="000000"/>
+            </a:solidFill>
+            <a:prstDash val="solid"/>
+            <a:miter lim="800000"/>
+          </a:ln>
+          <a:effectLst>
+            <a:outerShdw blurRad="50800" dist="38100" dir="2700000" algn="tl" rotWithShape="0">
+              <a:srgbClr val="000000">
+                <a:alpha val="43000"/>
+              </a:srgbClr>
+            </a:outerShdw>
+          </a:effectLst>
+        </p:spPr>
+      </p:pic>
     </p:spTree>
     <p:extLst>
       <p:ext uri="{BB962C8B-B14F-4D97-AF65-F5344CB8AC3E}">
@@ -3484,6 +3721,670 @@
 </file>
 
 <file path=ppt/slides/slide3.xml><?xml version="1.0" encoding="utf-8"?>
+<p:sld xmlns:a="http://schemas.openxmlformats.org/drawingml/2006/main" xmlns:r="http://schemas.openxmlformats.org/officeDocument/2006/relationships" xmlns:p="http://schemas.openxmlformats.org/presentationml/2006/main">
+  <p:cSld>
+    <p:spTree>
+      <p:nvGrpSpPr>
+        <p:cNvPr id="1" name="">
+          <a:extLst>
+            <a:ext uri="{FF2B5EF4-FFF2-40B4-BE49-F238E27FC236}">
+              <a16:creationId xmlns:a16="http://schemas.microsoft.com/office/drawing/2014/main" id="{F911937E-1201-08F9-AB70-6AD12C461575}"/>
+            </a:ext>
+          </a:extLst>
+        </p:cNvPr>
+        <p:cNvGrpSpPr/>
+        <p:nvPr/>
+      </p:nvGrpSpPr>
+      <p:grpSpPr>
+        <a:xfrm>
+          <a:off x="0" y="0"/>
+          <a:ext cx="0" cy="0"/>
+          <a:chOff x="0" y="0"/>
+          <a:chExt cx="0" cy="0"/>
+        </a:xfrm>
+      </p:grpSpPr>
+      <p:sp>
+        <p:nvSpPr>
+          <p:cNvPr id="3" name="TextBox 2">
+            <a:extLst>
+              <a:ext uri="{FF2B5EF4-FFF2-40B4-BE49-F238E27FC236}">
+                <a16:creationId xmlns:a16="http://schemas.microsoft.com/office/drawing/2014/main" id="{93576429-D493-3C1D-1C90-36687CD741DC}"/>
+              </a:ext>
+            </a:extLst>
+          </p:cNvPr>
+          <p:cNvSpPr txBox="1"/>
+          <p:nvPr/>
+        </p:nvSpPr>
+        <p:spPr>
+          <a:xfrm>
+            <a:off x="128649" y="190392"/>
+            <a:ext cx="6031345" cy="5152244"/>
+          </a:xfrm>
+          <a:prstGeom prst="rect">
+            <a:avLst/>
+          </a:prstGeom>
+          <a:noFill/>
+        </p:spPr>
+        <p:txBody>
+          <a:bodyPr wrap="square">
+            <a:spAutoFit/>
+          </a:bodyPr>
+          <a:lstStyle/>
+          <a:p>
+            <a:pPr>
+              <a:lnSpc>
+                <a:spcPct val="150000"/>
+              </a:lnSpc>
+              <a:buNone/>
+            </a:pPr>
+            <a:r>
+              <a:rPr lang="en-US" altLang="en-US" sz="1050" b="1">
+                <a:solidFill>
+                  <a:srgbClr val="FF0000"/>
+                </a:solidFill>
+                <a:latin typeface="Arial" panose="020B0604020202020204" pitchFamily="34" charset="0"/>
+              </a:rPr>
+              <a:t>$slider-&gt;banner = empty(!$imagePath); </a:t>
+            </a:r>
+            <a:r>
+              <a:rPr lang="en-US" altLang="en-US" sz="1050" b="1">
+                <a:latin typeface="Arial" panose="020B0604020202020204" pitchFamily="34" charset="0"/>
+              </a:rPr>
+              <a:t>burada olan məntiqi addım-addım izah edim</a:t>
+            </a:r>
+            <a:r>
+              <a:rPr lang="en-US" altLang="en-US" sz="1050">
+                <a:latin typeface="Arial" panose="020B0604020202020204" pitchFamily="34" charset="0"/>
+              </a:rPr>
+              <a:t>:</a:t>
+            </a:r>
+          </a:p>
+          <a:p>
+            <a:pPr>
+              <a:lnSpc>
+                <a:spcPct val="150000"/>
+              </a:lnSpc>
+              <a:buNone/>
+            </a:pPr>
+            <a:endParaRPr lang="en-US" altLang="en-US" sz="1050">
+              <a:latin typeface="Arial" panose="020B0604020202020204" pitchFamily="34" charset="0"/>
+            </a:endParaRPr>
+          </a:p>
+          <a:p>
+            <a:pPr>
+              <a:lnSpc>
+                <a:spcPct val="150000"/>
+              </a:lnSpc>
+              <a:buNone/>
+            </a:pPr>
+            <a:r>
+              <a:rPr lang="en-US" altLang="en-US" sz="1050" b="1">
+                <a:latin typeface="Arial" panose="020B0604020202020204" pitchFamily="34" charset="0"/>
+              </a:rPr>
+              <a:t>$imagePath </a:t>
+            </a:r>
+            <a:r>
+              <a:rPr lang="en-US" altLang="en-US" sz="1050">
+                <a:latin typeface="Arial" panose="020B0604020202020204" pitchFamily="34" charset="0"/>
+              </a:rPr>
+              <a:t>dəyişəni </a:t>
+            </a:r>
+            <a:r>
+              <a:rPr lang="en-US" altLang="en-US" sz="1050" b="1">
+                <a:latin typeface="Arial" panose="020B0604020202020204" pitchFamily="34" charset="0"/>
+              </a:rPr>
+              <a:t>updateImage() </a:t>
+            </a:r>
+            <a:r>
+              <a:rPr lang="en-US" altLang="en-US" sz="1050">
+                <a:latin typeface="Arial" panose="020B0604020202020204" pitchFamily="34" charset="0"/>
+              </a:rPr>
+              <a:t>metodundan qaytarılan nəticədir. Əgər yeni şəkil yüklənibsə, bu dəyişəndə şəkilin yolu (</a:t>
+            </a:r>
+            <a:r>
+              <a:rPr lang="en-US" altLang="en-US" sz="1050" b="1">
+                <a:solidFill>
+                  <a:srgbClr val="00B050"/>
+                </a:solidFill>
+                <a:latin typeface="Arial" panose="020B0604020202020204" pitchFamily="34" charset="0"/>
+              </a:rPr>
+              <a:t>string</a:t>
+            </a:r>
+            <a:r>
+              <a:rPr lang="en-US" altLang="en-US" sz="1050">
+                <a:latin typeface="Arial" panose="020B0604020202020204" pitchFamily="34" charset="0"/>
+              </a:rPr>
+              <a:t>) olacaq, əks halda </a:t>
+            </a:r>
+            <a:r>
+              <a:rPr lang="en-US" altLang="en-US" sz="1050" b="1">
+                <a:solidFill>
+                  <a:srgbClr val="00B050"/>
+                </a:solidFill>
+                <a:latin typeface="Arial" panose="020B0604020202020204" pitchFamily="34" charset="0"/>
+              </a:rPr>
+              <a:t>null</a:t>
+            </a:r>
+            <a:r>
+              <a:rPr lang="en-US" altLang="en-US" sz="1050">
+                <a:latin typeface="Arial" panose="020B0604020202020204" pitchFamily="34" charset="0"/>
+              </a:rPr>
+              <a:t> olacaq.</a:t>
+            </a:r>
+          </a:p>
+          <a:p>
+            <a:pPr>
+              <a:lnSpc>
+                <a:spcPct val="150000"/>
+              </a:lnSpc>
+              <a:buNone/>
+            </a:pPr>
+            <a:endParaRPr lang="en-US" altLang="en-US" sz="1050">
+              <a:latin typeface="Arial" panose="020B0604020202020204" pitchFamily="34" charset="0"/>
+            </a:endParaRPr>
+          </a:p>
+          <a:p>
+            <a:pPr>
+              <a:lnSpc>
+                <a:spcPct val="150000"/>
+              </a:lnSpc>
+              <a:buNone/>
+            </a:pPr>
+            <a:r>
+              <a:rPr lang="en-US" altLang="en-US" sz="1050" b="1">
+                <a:latin typeface="Arial" panose="020B0604020202020204" pitchFamily="34" charset="0"/>
+              </a:rPr>
+              <a:t>!$imagePath</a:t>
+            </a:r>
+            <a:r>
+              <a:rPr lang="en-US" altLang="en-US" sz="1050">
+                <a:latin typeface="Arial" panose="020B0604020202020204" pitchFamily="34" charset="0"/>
+              </a:rPr>
+              <a:t> →</a:t>
+            </a:r>
+          </a:p>
+          <a:p>
+            <a:pPr marL="171450" indent="-171450">
+              <a:lnSpc>
+                <a:spcPct val="150000"/>
+              </a:lnSpc>
+              <a:buFont typeface="Wingdings" panose="05000000000000000000" pitchFamily="2" charset="2"/>
+              <a:buChar char="q"/>
+            </a:pPr>
+            <a:r>
+              <a:rPr lang="en-US" altLang="en-US" sz="1050">
+                <a:latin typeface="Arial" panose="020B0604020202020204" pitchFamily="34" charset="0"/>
+              </a:rPr>
+              <a:t>Əgər </a:t>
+            </a:r>
+            <a:r>
+              <a:rPr lang="en-US" altLang="en-US" sz="1050" b="1">
+                <a:latin typeface="Arial" panose="020B0604020202020204" pitchFamily="34" charset="0"/>
+              </a:rPr>
+              <a:t>$imagePath </a:t>
+            </a:r>
+            <a:r>
+              <a:rPr lang="en-US" altLang="en-US" sz="1050" b="1">
+                <a:solidFill>
+                  <a:srgbClr val="00B050"/>
+                </a:solidFill>
+                <a:latin typeface="Arial" panose="020B0604020202020204" pitchFamily="34" charset="0"/>
+              </a:rPr>
+              <a:t>null</a:t>
+            </a:r>
+            <a:r>
+              <a:rPr lang="en-US" altLang="en-US" sz="1050">
+                <a:latin typeface="Arial" panose="020B0604020202020204" pitchFamily="34" charset="0"/>
+              </a:rPr>
+              <a:t> və ya boş stringdirsə </a:t>
+            </a:r>
+            <a:r>
+              <a:rPr lang="en-US" altLang="en-US" sz="1050" b="1">
+                <a:latin typeface="Arial" panose="020B0604020202020204" pitchFamily="34" charset="0"/>
+              </a:rPr>
+              <a:t>→ !$imagePath true</a:t>
+            </a:r>
+            <a:r>
+              <a:rPr lang="en-US" altLang="en-US" sz="1050">
+                <a:latin typeface="Arial" panose="020B0604020202020204" pitchFamily="34" charset="0"/>
+              </a:rPr>
+              <a:t> olacaq.</a:t>
+            </a:r>
+          </a:p>
+          <a:p>
+            <a:pPr marL="171450" indent="-171450">
+              <a:lnSpc>
+                <a:spcPct val="150000"/>
+              </a:lnSpc>
+              <a:buFont typeface="Wingdings" panose="05000000000000000000" pitchFamily="2" charset="2"/>
+              <a:buChar char="q"/>
+            </a:pPr>
+            <a:r>
+              <a:rPr lang="en-US" altLang="en-US" sz="1050">
+                <a:latin typeface="Arial" panose="020B0604020202020204" pitchFamily="34" charset="0"/>
+              </a:rPr>
+              <a:t>Əgər </a:t>
+            </a:r>
+            <a:r>
+              <a:rPr lang="en-US" altLang="en-US" sz="1050" b="1">
+                <a:latin typeface="Arial" panose="020B0604020202020204" pitchFamily="34" charset="0"/>
+              </a:rPr>
+              <a:t>$imagePath </a:t>
+            </a:r>
+            <a:r>
+              <a:rPr lang="en-US" altLang="en-US" sz="1050">
+                <a:latin typeface="Arial" panose="020B0604020202020204" pitchFamily="34" charset="0"/>
+              </a:rPr>
+              <a:t>doludursa (məs., "</a:t>
+            </a:r>
+            <a:r>
+              <a:rPr lang="en-US" altLang="en-US" sz="1050" b="1">
+                <a:latin typeface="Arial" panose="020B0604020202020204" pitchFamily="34" charset="0"/>
+              </a:rPr>
+              <a:t>uploads/media_123.jpg</a:t>
+            </a:r>
+            <a:r>
+              <a:rPr lang="en-US" altLang="en-US" sz="1050">
+                <a:latin typeface="Arial" panose="020B0604020202020204" pitchFamily="34" charset="0"/>
+              </a:rPr>
+              <a:t>") → </a:t>
+            </a:r>
+            <a:r>
+              <a:rPr lang="en-US" altLang="en-US" sz="1050" b="1">
+                <a:latin typeface="Arial" panose="020B0604020202020204" pitchFamily="34" charset="0"/>
+              </a:rPr>
+              <a:t>!$imagePath false</a:t>
+            </a:r>
+            <a:r>
+              <a:rPr lang="en-US" altLang="en-US" sz="1050">
+                <a:latin typeface="Arial" panose="020B0604020202020204" pitchFamily="34" charset="0"/>
+              </a:rPr>
+              <a:t> olacaq.</a:t>
+            </a:r>
+          </a:p>
+          <a:p>
+            <a:pPr>
+              <a:lnSpc>
+                <a:spcPct val="150000"/>
+              </a:lnSpc>
+              <a:buNone/>
+            </a:pPr>
+            <a:endParaRPr lang="en-US" altLang="en-US" sz="1050">
+              <a:latin typeface="Arial" panose="020B0604020202020204" pitchFamily="34" charset="0"/>
+            </a:endParaRPr>
+          </a:p>
+          <a:p>
+            <a:pPr>
+              <a:lnSpc>
+                <a:spcPct val="150000"/>
+              </a:lnSpc>
+              <a:buNone/>
+            </a:pPr>
+            <a:endParaRPr lang="en-US" altLang="en-US" sz="1050">
+              <a:latin typeface="Arial" panose="020B0604020202020204" pitchFamily="34" charset="0"/>
+            </a:endParaRPr>
+          </a:p>
+          <a:p>
+            <a:pPr>
+              <a:lnSpc>
+                <a:spcPct val="150000"/>
+              </a:lnSpc>
+              <a:buNone/>
+            </a:pPr>
+            <a:r>
+              <a:rPr lang="en-US" altLang="en-US" sz="1050" b="1">
+                <a:latin typeface="Arial" panose="020B0604020202020204" pitchFamily="34" charset="0"/>
+              </a:rPr>
+              <a:t>empty(!$imagePath) </a:t>
+            </a:r>
+            <a:r>
+              <a:rPr lang="en-US" altLang="en-US" sz="1050">
+                <a:latin typeface="Arial" panose="020B0604020202020204" pitchFamily="34" charset="0"/>
+              </a:rPr>
+              <a:t>→</a:t>
+            </a:r>
+          </a:p>
+          <a:p>
+            <a:pPr marL="171450" indent="-171450">
+              <a:lnSpc>
+                <a:spcPct val="150000"/>
+              </a:lnSpc>
+              <a:buFont typeface="Wingdings" panose="05000000000000000000" pitchFamily="2" charset="2"/>
+              <a:buChar char="q"/>
+            </a:pPr>
+            <a:r>
+              <a:rPr lang="en-US" altLang="en-US" sz="1050" b="1">
+                <a:latin typeface="Arial" panose="020B0604020202020204" pitchFamily="34" charset="0"/>
+              </a:rPr>
+              <a:t>empty() </a:t>
+            </a:r>
+            <a:r>
+              <a:rPr lang="en-US" altLang="en-US" sz="1050">
+                <a:latin typeface="Arial" panose="020B0604020202020204" pitchFamily="34" charset="0"/>
+              </a:rPr>
+              <a:t>funksiyası </a:t>
+            </a:r>
+            <a:r>
+              <a:rPr lang="en-US" altLang="en-US" sz="1050" b="1">
+                <a:latin typeface="Arial" panose="020B0604020202020204" pitchFamily="34" charset="0"/>
+              </a:rPr>
+              <a:t>true</a:t>
+            </a:r>
+            <a:r>
+              <a:rPr lang="en-US" altLang="en-US" sz="1050">
+                <a:latin typeface="Arial" panose="020B0604020202020204" pitchFamily="34" charset="0"/>
+              </a:rPr>
+              <a:t> və ya </a:t>
+            </a:r>
+            <a:r>
+              <a:rPr lang="en-US" altLang="en-US" sz="1050" b="1">
+                <a:latin typeface="Arial" panose="020B0604020202020204" pitchFamily="34" charset="0"/>
+              </a:rPr>
+              <a:t>false</a:t>
+            </a:r>
+            <a:r>
+              <a:rPr lang="en-US" altLang="en-US" sz="1050">
+                <a:latin typeface="Arial" panose="020B0604020202020204" pitchFamily="34" charset="0"/>
+              </a:rPr>
+              <a:t>-u yoxlayır və nəticə </a:t>
+            </a:r>
+            <a:r>
+              <a:rPr lang="en-US" altLang="en-US" sz="1050" b="1">
+                <a:latin typeface="Arial" panose="020B0604020202020204" pitchFamily="34" charset="0"/>
+              </a:rPr>
+              <a:t>true</a:t>
+            </a:r>
+            <a:r>
+              <a:rPr lang="en-US" altLang="en-US" sz="1050">
+                <a:latin typeface="Arial" panose="020B0604020202020204" pitchFamily="34" charset="0"/>
+              </a:rPr>
+              <a:t> isə 1-ci, </a:t>
+            </a:r>
+            <a:r>
+              <a:rPr lang="en-US" altLang="en-US" sz="1050" b="1">
+                <a:latin typeface="Arial" panose="020B0604020202020204" pitchFamily="34" charset="0"/>
+              </a:rPr>
+              <a:t>false</a:t>
+            </a:r>
+            <a:r>
+              <a:rPr lang="en-US" altLang="en-US" sz="1050">
+                <a:latin typeface="Arial" panose="020B0604020202020204" pitchFamily="34" charset="0"/>
+              </a:rPr>
+              <a:t> isə 0 qaytarır.</a:t>
+            </a:r>
+          </a:p>
+          <a:p>
+            <a:pPr marL="171450" indent="-171450">
+              <a:lnSpc>
+                <a:spcPct val="150000"/>
+              </a:lnSpc>
+              <a:buFont typeface="Wingdings" panose="05000000000000000000" pitchFamily="2" charset="2"/>
+              <a:buChar char="q"/>
+            </a:pPr>
+            <a:r>
+              <a:rPr lang="en-US" altLang="en-US" sz="1050">
+                <a:latin typeface="Arial" panose="020B0604020202020204" pitchFamily="34" charset="0"/>
+              </a:rPr>
+              <a:t>Yəni əslində bu </a:t>
+            </a:r>
+            <a:r>
+              <a:rPr lang="en-US" altLang="en-US" sz="1050" b="1">
+                <a:latin typeface="Arial" panose="020B0604020202020204" pitchFamily="34" charset="0"/>
+              </a:rPr>
+              <a:t>ifadə</a:t>
+            </a:r>
+            <a:r>
+              <a:rPr lang="en-US" altLang="en-US" sz="1050">
+                <a:latin typeface="Arial" panose="020B0604020202020204" pitchFamily="34" charset="0"/>
+              </a:rPr>
+              <a:t> boolean dəyərin əksinə çevrilmiş variantını yoxlayır.</a:t>
+            </a:r>
+          </a:p>
+          <a:p>
+            <a:pPr>
+              <a:lnSpc>
+                <a:spcPct val="150000"/>
+              </a:lnSpc>
+              <a:buNone/>
+            </a:pPr>
+            <a:endParaRPr lang="en-US" altLang="en-US" sz="1050">
+              <a:latin typeface="Arial" panose="020B0604020202020204" pitchFamily="34" charset="0"/>
+            </a:endParaRPr>
+          </a:p>
+          <a:p>
+            <a:pPr>
+              <a:lnSpc>
+                <a:spcPct val="150000"/>
+              </a:lnSpc>
+              <a:buNone/>
+            </a:pPr>
+            <a:endParaRPr lang="en-US" altLang="en-US" sz="1050">
+              <a:latin typeface="Arial" panose="020B0604020202020204" pitchFamily="34" charset="0"/>
+            </a:endParaRPr>
+          </a:p>
+          <a:p>
+            <a:pPr>
+              <a:lnSpc>
+                <a:spcPct val="150000"/>
+              </a:lnSpc>
+              <a:buNone/>
+            </a:pPr>
+            <a:r>
+              <a:rPr lang="en-US" altLang="en-US" sz="1050" b="1">
+                <a:latin typeface="Arial" panose="020B0604020202020204" pitchFamily="34" charset="0"/>
+              </a:rPr>
+              <a:t>Nəticə olaraq</a:t>
+            </a:r>
+            <a:r>
+              <a:rPr lang="en-US" altLang="en-US" sz="1050">
+                <a:latin typeface="Arial" panose="020B0604020202020204" pitchFamily="34" charset="0"/>
+              </a:rPr>
+              <a:t>:</a:t>
+            </a:r>
+          </a:p>
+          <a:p>
+            <a:pPr marL="171450" indent="-171450">
+              <a:lnSpc>
+                <a:spcPct val="150000"/>
+              </a:lnSpc>
+              <a:buFont typeface="Wingdings" panose="05000000000000000000" pitchFamily="2" charset="2"/>
+              <a:buChar char="q"/>
+            </a:pPr>
+            <a:r>
+              <a:rPr lang="en-US" altLang="en-US" sz="1050" b="1">
+                <a:latin typeface="Arial" panose="020B0604020202020204" pitchFamily="34" charset="0"/>
+              </a:rPr>
+              <a:t>$imagePath </a:t>
+            </a:r>
+            <a:r>
+              <a:rPr lang="en-US" altLang="en-US" sz="1050">
+                <a:latin typeface="Arial" panose="020B0604020202020204" pitchFamily="34" charset="0"/>
+              </a:rPr>
+              <a:t>varsa → </a:t>
+            </a:r>
+            <a:r>
+              <a:rPr lang="en-US" altLang="en-US" sz="1050" b="1">
+                <a:latin typeface="Arial" panose="020B0604020202020204" pitchFamily="34" charset="0"/>
+              </a:rPr>
+              <a:t>!$imagePath = false </a:t>
+            </a:r>
+            <a:r>
+              <a:rPr lang="en-US" altLang="en-US" sz="1050">
+                <a:latin typeface="Arial" panose="020B0604020202020204" pitchFamily="34" charset="0"/>
+              </a:rPr>
+              <a:t>→ </a:t>
+            </a:r>
+            <a:r>
+              <a:rPr lang="en-US" altLang="en-US" sz="1050" b="1">
+                <a:latin typeface="Arial" panose="020B0604020202020204" pitchFamily="34" charset="0"/>
+              </a:rPr>
+              <a:t>empty(false) = true </a:t>
+            </a:r>
+            <a:r>
+              <a:rPr lang="en-US" altLang="en-US" sz="1050">
+                <a:latin typeface="Arial" panose="020B0604020202020204" pitchFamily="34" charset="0"/>
+              </a:rPr>
+              <a:t>(yəni 1).</a:t>
+            </a:r>
+          </a:p>
+          <a:p>
+            <a:pPr marL="171450" indent="-171450">
+              <a:lnSpc>
+                <a:spcPct val="150000"/>
+              </a:lnSpc>
+              <a:buFont typeface="Wingdings" panose="05000000000000000000" pitchFamily="2" charset="2"/>
+              <a:buChar char="q"/>
+            </a:pPr>
+            <a:r>
+              <a:rPr lang="en-US" altLang="en-US" sz="1050" b="1">
+                <a:latin typeface="Arial" panose="020B0604020202020204" pitchFamily="34" charset="0"/>
+              </a:rPr>
+              <a:t>$imagePath </a:t>
+            </a:r>
+            <a:r>
+              <a:rPr lang="en-US" altLang="en-US" sz="1050">
+                <a:latin typeface="Arial" panose="020B0604020202020204" pitchFamily="34" charset="0"/>
+              </a:rPr>
+              <a:t>yoxdursa → </a:t>
+            </a:r>
+            <a:r>
+              <a:rPr lang="en-US" altLang="en-US" sz="1050" b="1">
+                <a:latin typeface="Arial" panose="020B0604020202020204" pitchFamily="34" charset="0"/>
+              </a:rPr>
+              <a:t>!$imagePath = true </a:t>
+            </a:r>
+            <a:r>
+              <a:rPr lang="en-US" altLang="en-US" sz="1050">
+                <a:latin typeface="Arial" panose="020B0604020202020204" pitchFamily="34" charset="0"/>
+              </a:rPr>
+              <a:t>→ </a:t>
+            </a:r>
+            <a:r>
+              <a:rPr lang="en-US" altLang="en-US" sz="1050" b="1">
+                <a:latin typeface="Arial" panose="020B0604020202020204" pitchFamily="34" charset="0"/>
+              </a:rPr>
+              <a:t>empty(true) = false </a:t>
+            </a:r>
+            <a:r>
+              <a:rPr lang="en-US" altLang="en-US" sz="1050">
+                <a:latin typeface="Arial" panose="020B0604020202020204" pitchFamily="34" charset="0"/>
+              </a:rPr>
+              <a:t>(yəni 0).</a:t>
+            </a:r>
+          </a:p>
+          <a:p>
+            <a:pPr marL="171450" indent="-171450">
+              <a:lnSpc>
+                <a:spcPct val="150000"/>
+              </a:lnSpc>
+              <a:buFont typeface="Wingdings" panose="05000000000000000000" pitchFamily="2" charset="2"/>
+              <a:buChar char="q"/>
+            </a:pPr>
+            <a:endParaRPr kumimoji="0" lang="az-Latn-AZ" altLang="en-US" sz="1050" b="0" i="0" u="none" strike="noStrike" cap="none" normalizeH="0" baseline="0">
+              <a:ln>
+                <a:noFill/>
+              </a:ln>
+              <a:solidFill>
+                <a:schemeClr val="tx1"/>
+              </a:solidFill>
+              <a:effectLst/>
+              <a:latin typeface="Arial" panose="020B0604020202020204" pitchFamily="34" charset="0"/>
+            </a:endParaRPr>
+          </a:p>
+          <a:p>
+            <a:pPr marL="171450" indent="-171450">
+              <a:lnSpc>
+                <a:spcPct val="150000"/>
+              </a:lnSpc>
+              <a:buFont typeface="Wingdings" panose="05000000000000000000" pitchFamily="2" charset="2"/>
+              <a:buChar char="q"/>
+            </a:pPr>
+            <a:endParaRPr kumimoji="0" lang="en-US" altLang="en-US" sz="1050" b="0" i="0" u="none" strike="noStrike" cap="none" normalizeH="0" baseline="0">
+              <a:ln>
+                <a:noFill/>
+              </a:ln>
+              <a:solidFill>
+                <a:schemeClr val="tx1"/>
+              </a:solidFill>
+              <a:effectLst/>
+              <a:latin typeface="Arial" panose="020B0604020202020204" pitchFamily="34" charset="0"/>
+            </a:endParaRPr>
+          </a:p>
+          <a:p>
+            <a:pPr>
+              <a:lnSpc>
+                <a:spcPct val="150000"/>
+              </a:lnSpc>
+            </a:pPr>
+            <a:r>
+              <a:rPr lang="en-US" altLang="en-US" sz="1050">
+                <a:latin typeface="Arial" panose="020B0604020202020204" pitchFamily="34" charset="0"/>
+              </a:rPr>
+              <a:t>Sonra i</a:t>
+            </a:r>
+            <a:r>
+              <a:rPr lang="az-Latn-AZ" altLang="en-US" sz="1050">
+                <a:latin typeface="Arial" panose="020B0604020202020204" pitchFamily="34" charset="0"/>
+              </a:rPr>
+              <a:t>sə, şərt qoşaraq, yeni şəkli yaxud mövcud şəkli yükləyirik.</a:t>
+            </a:r>
+            <a:endParaRPr kumimoji="0" lang="en-US" altLang="en-US" sz="1050" b="0" i="0" u="none" strike="noStrike" cap="none" normalizeH="0" baseline="0">
+              <a:ln>
+                <a:noFill/>
+              </a:ln>
+              <a:solidFill>
+                <a:schemeClr val="tx1"/>
+              </a:solidFill>
+              <a:effectLst/>
+              <a:latin typeface="Arial" panose="020B0604020202020204" pitchFamily="34" charset="0"/>
+            </a:endParaRPr>
+          </a:p>
+        </p:txBody>
+      </p:sp>
+      <p:pic>
+        <p:nvPicPr>
+          <p:cNvPr id="5" name="Picture 4">
+            <a:extLst>
+              <a:ext uri="{FF2B5EF4-FFF2-40B4-BE49-F238E27FC236}">
+                <a16:creationId xmlns:a16="http://schemas.microsoft.com/office/drawing/2014/main" id="{82286570-AAAD-BD92-173F-2B9548D0B889}"/>
+              </a:ext>
+            </a:extLst>
+          </p:cNvPr>
+          <p:cNvPicPr>
+            <a:picLocks noChangeAspect="1"/>
+          </p:cNvPicPr>
+          <p:nvPr/>
+        </p:nvPicPr>
+        <p:blipFill>
+          <a:blip r:embed="rId2"/>
+          <a:stretch>
+            <a:fillRect/>
+          </a:stretch>
+        </p:blipFill>
+        <p:spPr>
+          <a:xfrm>
+            <a:off x="6224649" y="0"/>
+            <a:ext cx="5967351" cy="6858000"/>
+          </a:xfrm>
+          <a:prstGeom prst="rect">
+            <a:avLst/>
+          </a:prstGeom>
+        </p:spPr>
+      </p:pic>
+    </p:spTree>
+    <p:extLst>
+      <p:ext uri="{BB962C8B-B14F-4D97-AF65-F5344CB8AC3E}">
+        <p14:creationId xmlns:p14="http://schemas.microsoft.com/office/powerpoint/2010/main" val="140704782"/>
+      </p:ext>
+    </p:extLst>
+  </p:cSld>
+  <p:clrMapOvr>
+    <a:masterClrMapping/>
+  </p:clrMapOvr>
+</p:sld>
+</file>
+
+<file path=ppt/slides/slide4.xml><?xml version="1.0" encoding="utf-8"?>
 <p:sld xmlns:a="http://schemas.openxmlformats.org/drawingml/2006/main" xmlns:r="http://schemas.openxmlformats.org/officeDocument/2006/relationships" xmlns:p="http://schemas.openxmlformats.org/presentationml/2006/main">
   <p:cSld>
     <p:spTree>
@@ -3560,6 +4461,178 @@
     <p:extLst>
       <p:ext uri="{BB962C8B-B14F-4D97-AF65-F5344CB8AC3E}">
         <p14:creationId xmlns:p14="http://schemas.microsoft.com/office/powerpoint/2010/main" val="3095838342"/>
+      </p:ext>
+    </p:extLst>
+  </p:cSld>
+  <p:clrMapOvr>
+    <a:masterClrMapping/>
+  </p:clrMapOvr>
+</p:sld>
+</file>
+
+<file path=ppt/slides/slide5.xml><?xml version="1.0" encoding="utf-8"?>
+<p:sld xmlns:a="http://schemas.openxmlformats.org/drawingml/2006/main" xmlns:r="http://schemas.openxmlformats.org/officeDocument/2006/relationships" xmlns:p="http://schemas.openxmlformats.org/presentationml/2006/main">
+  <p:cSld>
+    <p:spTree>
+      <p:nvGrpSpPr>
+        <p:cNvPr id="1" name="">
+          <a:extLst>
+            <a:ext uri="{FF2B5EF4-FFF2-40B4-BE49-F238E27FC236}">
+              <a16:creationId xmlns:a16="http://schemas.microsoft.com/office/drawing/2014/main" id="{B229B91B-03DB-D37F-84E7-168AF013B5B3}"/>
+            </a:ext>
+          </a:extLst>
+        </p:cNvPr>
+        <p:cNvGrpSpPr/>
+        <p:nvPr/>
+      </p:nvGrpSpPr>
+      <p:grpSpPr>
+        <a:xfrm>
+          <a:off x="0" y="0"/>
+          <a:ext cx="0" cy="0"/>
+          <a:chOff x="0" y="0"/>
+          <a:chExt cx="0" cy="0"/>
+        </a:xfrm>
+      </p:grpSpPr>
+      <p:sp>
+        <p:nvSpPr>
+          <p:cNvPr id="3" name="TextBox 2">
+            <a:extLst>
+              <a:ext uri="{FF2B5EF4-FFF2-40B4-BE49-F238E27FC236}">
+                <a16:creationId xmlns:a16="http://schemas.microsoft.com/office/drawing/2014/main" id="{99E74456-CFFD-0ABF-C19F-E5667A461650}"/>
+              </a:ext>
+            </a:extLst>
+          </p:cNvPr>
+          <p:cNvSpPr txBox="1"/>
+          <p:nvPr/>
+        </p:nvSpPr>
+        <p:spPr>
+          <a:xfrm>
+            <a:off x="217714" y="255046"/>
+            <a:ext cx="11756571" cy="355354"/>
+          </a:xfrm>
+          <a:prstGeom prst="rect">
+            <a:avLst/>
+          </a:prstGeom>
+          <a:noFill/>
+        </p:spPr>
+        <p:txBody>
+          <a:bodyPr wrap="square">
+            <a:spAutoFit/>
+          </a:bodyPr>
+          <a:lstStyle/>
+          <a:p>
+            <a:pPr>
+              <a:lnSpc>
+                <a:spcPct val="150000"/>
+              </a:lnSpc>
+              <a:buNone/>
+            </a:pPr>
+            <a:r>
+              <a:rPr kumimoji="0" lang="en-US" altLang="en-US" sz="1300" b="0" i="0" u="none" strike="noStrike" cap="none" normalizeH="0" baseline="0">
+                <a:ln>
+                  <a:noFill/>
+                </a:ln>
+                <a:solidFill>
+                  <a:schemeClr val="tx1"/>
+                </a:solidFill>
+                <a:effectLst/>
+                <a:latin typeface="Arial" panose="020B0604020202020204" pitchFamily="34" charset="0"/>
+              </a:rPr>
+              <a:t>.</a:t>
+            </a:r>
+          </a:p>
+        </p:txBody>
+      </p:sp>
+    </p:spTree>
+    <p:extLst>
+      <p:ext uri="{BB962C8B-B14F-4D97-AF65-F5344CB8AC3E}">
+        <p14:creationId xmlns:p14="http://schemas.microsoft.com/office/powerpoint/2010/main" val="2844057610"/>
+      </p:ext>
+    </p:extLst>
+  </p:cSld>
+  <p:clrMapOvr>
+    <a:masterClrMapping/>
+  </p:clrMapOvr>
+</p:sld>
+</file>
+
+<file path=ppt/slides/slide6.xml><?xml version="1.0" encoding="utf-8"?>
+<p:sld xmlns:a="http://schemas.openxmlformats.org/drawingml/2006/main" xmlns:r="http://schemas.openxmlformats.org/officeDocument/2006/relationships" xmlns:p="http://schemas.openxmlformats.org/presentationml/2006/main">
+  <p:cSld>
+    <p:spTree>
+      <p:nvGrpSpPr>
+        <p:cNvPr id="1" name="">
+          <a:extLst>
+            <a:ext uri="{FF2B5EF4-FFF2-40B4-BE49-F238E27FC236}">
+              <a16:creationId xmlns:a16="http://schemas.microsoft.com/office/drawing/2014/main" id="{42FCE782-DC77-9FE9-8304-BA53C7C6164F}"/>
+            </a:ext>
+          </a:extLst>
+        </p:cNvPr>
+        <p:cNvGrpSpPr/>
+        <p:nvPr/>
+      </p:nvGrpSpPr>
+      <p:grpSpPr>
+        <a:xfrm>
+          <a:off x="0" y="0"/>
+          <a:ext cx="0" cy="0"/>
+          <a:chOff x="0" y="0"/>
+          <a:chExt cx="0" cy="0"/>
+        </a:xfrm>
+      </p:grpSpPr>
+      <p:sp>
+        <p:nvSpPr>
+          <p:cNvPr id="3" name="TextBox 2">
+            <a:extLst>
+              <a:ext uri="{FF2B5EF4-FFF2-40B4-BE49-F238E27FC236}">
+                <a16:creationId xmlns:a16="http://schemas.microsoft.com/office/drawing/2014/main" id="{DA4BDA67-AE1E-C89C-477C-B5B49E9772A8}"/>
+              </a:ext>
+            </a:extLst>
+          </p:cNvPr>
+          <p:cNvSpPr txBox="1"/>
+          <p:nvPr/>
+        </p:nvSpPr>
+        <p:spPr>
+          <a:xfrm>
+            <a:off x="217714" y="255046"/>
+            <a:ext cx="11756571" cy="355354"/>
+          </a:xfrm>
+          <a:prstGeom prst="rect">
+            <a:avLst/>
+          </a:prstGeom>
+          <a:noFill/>
+        </p:spPr>
+        <p:txBody>
+          <a:bodyPr wrap="square">
+            <a:spAutoFit/>
+          </a:bodyPr>
+          <a:lstStyle/>
+          <a:p>
+            <a:pPr>
+              <a:lnSpc>
+                <a:spcPct val="150000"/>
+              </a:lnSpc>
+              <a:buNone/>
+            </a:pPr>
+            <a:r>
+              <a:rPr kumimoji="0" lang="en-US" altLang="en-US" sz="1300" b="0" i="0" u="none" strike="noStrike" cap="none" normalizeH="0" baseline="0">
+                <a:ln>
+                  <a:noFill/>
+                </a:ln>
+                <a:solidFill>
+                  <a:schemeClr val="tx1"/>
+                </a:solidFill>
+                <a:effectLst/>
+                <a:latin typeface="Arial" panose="020B0604020202020204" pitchFamily="34" charset="0"/>
+              </a:rPr>
+              <a:t>.</a:t>
+            </a:r>
+          </a:p>
+        </p:txBody>
+      </p:sp>
+    </p:spTree>
+    <p:extLst>
+      <p:ext uri="{BB962C8B-B14F-4D97-AF65-F5344CB8AC3E}">
+        <p14:creationId xmlns:p14="http://schemas.microsoft.com/office/powerpoint/2010/main" val="1904853963"/>
       </p:ext>
     </p:extLst>
   </p:cSld>

</xml_diff>